<commit_message>
feat: flag sin_stock para SKUs en catalogo sin reporte (v1.5.0)
</commit_message>
<xml_diff>
--- a/Manual_API_Equipo.pptx
+++ b/Manual_API_Equipo.pptx
@@ -1044,7 +1044,7 @@
           <a:p>
             <a:r>
               <a:rPr lang="en-US" dirty="0"/>
-              <a:t>El manual termina con las tres rutas útiles: la documentación interactiva, el repositorio del servicio y la versión vigente (1.4.0).</a:t>
+              <a:t>El manual termina con las tres rutas útiles: la documentación interactiva, el repositorio del servicio y la versión vigente (1.5.0).</a:t>
             </a:r>
             <a:endParaRPr lang="en-US" dirty="0"/>
           </a:p>
@@ -2196,7 +2196,7 @@
                 <a:ea typeface="Calibri" pitchFamily="34" charset="-122"/>
                 <a:cs typeface="Calibri" pitchFamily="34" charset="-120"/>
               </a:rPr>
-              <a:t>Manual de acceso para el equipo · v1.4.0</a:t>
+              <a:t>Manual de acceso para el equipo · v1.5.0</a:t>
             </a:r>
             <a:endParaRPr lang="en-US" sz="1800" dirty="0"/>
           </a:p>
@@ -6959,7 +6959,7 @@
                 <a:ea typeface="Calibri" pitchFamily="34" charset="-122"/>
                 <a:cs typeface="Calibri" pitchFamily="34" charset="-120"/>
               </a:rPr>
-              <a:t>Swagger /docs · Repositorio github.com/carloscus/g360-stock-api · v1.4.0</a:t>
+              <a:t>Swagger /docs · Repositorio github.com/carloscus/g360-stock-api · v1.5.0</a:t>
             </a:r>
             <a:endParaRPr lang="en-US" sz="1800" dirty="0"/>
           </a:p>

</xml_diff>

<commit_message>
feat: flag descontinuado del catalogo maestro + bump v1.6.0 (deck manual regenerado)
</commit_message>
<xml_diff>
--- a/Manual_API_Equipo.pptx
+++ b/Manual_API_Equipo.pptx
@@ -1044,7 +1044,7 @@
           <a:p>
             <a:r>
               <a:rPr lang="en-US" dirty="0"/>
-              <a:t>El manual termina con las tres rutas útiles: la documentación interactiva, el repositorio del servicio y la versión vigente (1.5.0).</a:t>
+              <a:t>El manual termina con las tres rutas útiles: la documentación interactiva, el repositorio del servicio y la versión vigente (1.6.0).</a:t>
             </a:r>
             <a:endParaRPr lang="en-US" dirty="0"/>
           </a:p>
@@ -2196,7 +2196,7 @@
                 <a:ea typeface="Calibri" pitchFamily="34" charset="-122"/>
                 <a:cs typeface="Calibri" pitchFamily="34" charset="-120"/>
               </a:rPr>
-              <a:t>Manual de acceso para el equipo · v1.5.0</a:t>
+              <a:t>Manual de acceso para el equipo · v1.6.0</a:t>
             </a:r>
             <a:endParaRPr lang="en-US" sz="1800" dirty="0"/>
           </a:p>
@@ -6959,7 +6959,7 @@
                 <a:ea typeface="Calibri" pitchFamily="34" charset="-122"/>
                 <a:cs typeface="Calibri" pitchFamily="34" charset="-120"/>
               </a:rPr>
-              <a:t>Swagger /docs · Repositorio github.com/carloscus/g360-stock-api · v1.5.0</a:t>
+              <a:t>Swagger /docs · Repositorio github.com/carloscus/g360-stock-api · v1.6.0</a:t>
             </a:r>
             <a:endParaRPr lang="en-US" sz="1800" dirty="0"/>
           </a:p>

</xml_diff>